<commit_message>
Simplify 3D query label
</commit_message>
<xml_diff>
--- a/labs_forum/heads4c.pptx
+++ b/labs_forum/heads4c.pptx
@@ -4522,7 +4522,7 @@
                 </a:solidFill>
                 <a:latin typeface="Work Sans"/>
               </a:rPr>
-              <a:t>query: (u, v, t_src, t_tgt)</a:t>
+              <a:t>query: (u, v, t)</a:t>
             </a:r>
           </a:p>
         </p:txBody>
@@ -6046,7 +6046,7 @@
                 </a:solidFill>
                 <a:latin typeface="Work Sans"/>
               </a:rPr>
-              <a:t>query: (u, v, t_src, t_tgt)</a:t>
+              <a:t>query: (u, v, t)</a:t>
             </a:r>
           </a:p>
         </p:txBody>
@@ -7708,7 +7708,7 @@
                 </a:solidFill>
                 <a:latin typeface="Work Sans"/>
               </a:rPr>
-              <a:t>query: (u, v, t_src, t_tgt)</a:t>
+              <a:t>query: (u, v, t)</a:t>
             </a:r>
           </a:p>
         </p:txBody>
@@ -9370,7 +9370,7 @@
                 </a:solidFill>
                 <a:latin typeface="Work Sans"/>
               </a:rPr>
-              <a:t>query: (u, v, t_src, t_tgt)</a:t>
+              <a:t>query: (u, v, t)</a:t>
             </a:r>
           </a:p>
         </p:txBody>
@@ -11032,7 +11032,7 @@
                 </a:solidFill>
                 <a:latin typeface="Work Sans"/>
               </a:rPr>
-              <a:t>query: (u, v, t_src, t_tgt)</a:t>
+              <a:t>query: (u, v, t)</a:t>
             </a:r>
           </a:p>
         </p:txBody>

</xml_diff>